<commit_message>
Expand disclaimer: personal capacity, not affiliated with numericor
</commit_message>
<xml_diff>
--- a/claude-code-workshop.pptx
+++ b/claude-code-workshop.pptx
@@ -8572,6 +8572,46 @@
                 <a:ea typeface="Inter" pitchFamily="34" charset="-122"/>
                 <a:cs typeface="Inter" pitchFamily="34" charset="-120"/>
               </a:rPr>
+              <a:t>This workshop is presented by Elias Karabelas in a personal capacity. It is not affiliated with, endorsed by, or conducted on behalf of numericor. The views, workflows, and recommendations expressed here are solely those of the presenter and do not represent numericor’s products, services, or business activities.</a:t>
+            </a:r>
+            <a:endParaRPr lang="en-US" sz="1600" dirty="0"/>
+          </a:p>
+          <a:p>
+            <a:pPr indent="0" marL="0">
+              <a:spcAft>
+                <a:spcPts val="400"/>
+              </a:spcAft>
+              <a:buNone/>
+            </a:pPr>
+            <a:r>
+              <a:rPr lang="en-US" sz="800" dirty="0">
+                <a:solidFill>
+                  <a:srgbClr val="000000"/>
+                </a:solidFill>
+                <a:latin typeface="Inter" pitchFamily="34" charset="0"/>
+                <a:ea typeface="Inter" pitchFamily="34" charset="-122"/>
+                <a:cs typeface="Inter" pitchFamily="34" charset="-120"/>
+              </a:rPr>
+              <a:t> </a:t>
+            </a:r>
+            <a:endParaRPr lang="en-US" sz="1600" dirty="0"/>
+          </a:p>
+          <a:p>
+            <a:pPr indent="0" marL="0">
+              <a:spcAft>
+                <a:spcPts val="400"/>
+              </a:spcAft>
+              <a:buNone/>
+            </a:pPr>
+            <a:r>
+              <a:rPr lang="en-US" sz="1600" dirty="0">
+                <a:solidFill>
+                  <a:srgbClr val="000000"/>
+                </a:solidFill>
+                <a:latin typeface="Inter" pitchFamily="34" charset="0"/>
+                <a:ea typeface="Inter" pitchFamily="34" charset="-122"/>
+                <a:cs typeface="Inter" pitchFamily="34" charset="-120"/>
+              </a:rPr>
               <a:t>These materials are provided for educational purposes only. The author makes no warranties, express or implied, regarding the accuracy, completeness, or fitness for any particular purpose of the information contained herein.</a:t>
             </a:r>
             <a:endParaRPr lang="en-US" sz="1600" dirty="0"/>

</xml_diff>